<commit_message>
fixed everything now... yea
</commit_message>
<xml_diff>
--- a/docs/lectures/index.pptx
+++ b/docs/lectures/index.pptx
@@ -3299,6 +3299,36 @@
           </a:p>
         </p:txBody>
       </p:sp>
+      <p:sp>
+        <p:nvSpPr>
+          <p:cNvPr id="3" name="Subtitle 2"/>
+          <p:cNvSpPr>
+            <a:spLocks noGrp="1"/>
+          </p:cNvSpPr>
+          <p:nvPr>
+            <p:ph idx="1" type="subTitle"/>
+          </p:nvPr>
+        </p:nvSpPr>
+        <p:spPr>
+          <a:xfrm>
+            <a:off x="255722" y="565689"/>
+            <a:ext cx="6400800" cy="1314450"/>
+          </a:xfrm>
+        </p:spPr>
+        <p:txBody>
+          <a:bodyPr/>
+          <a:lstStyle/>
+          <a:p>
+            <a:pPr lvl="0" indent="0" marL="0">
+              <a:buNone/>
+            </a:pPr>
+            <a:r>
+              <a:rPr/>
+              <a:t>Bill Perry</a:t>
+            </a:r>
+          </a:p>
+        </p:txBody>
+      </p:sp>
     </p:spTree>
   </p:cSld>
 </p:sld>
@@ -3341,7 +3371,7 @@
             </a:pPr>
             <a:r>
               <a:rPr/>
-              <a:t>Welcome to the course lectures. Click on any card below to view the slides and materials for that topic, or use the search bar to find a specific lecture.</a:t>
+              <a:t>These are all the lectures so far</a:t>
             </a:r>
           </a:p>
         </p:txBody>

</xml_diff>